<commit_message>
Revision Abb. 3.44 (Untertitel einzeilig), 3.193 (Zielniveau, Cashflow-Achse, Bandbreiten)
Co-Authored-By: Claude Sonnet 5.5 <noreply@anthropic.com>
Claude-Session: https://claude.ai/code/session_01UpMc9f3TdvJxhDzXRh8rp3
</commit_message>
<xml_diff>
--- a/abbildungen/kap3/Risiko-_und_Bandbreitenplanung_mit_der_Monte-Carlo-Simulation.pptx
+++ b/abbildungen/kap3/Risiko-_und_Bandbreitenplanung_mit_der_Monte-Carlo-Simulation.pptx
@@ -7590,8 +7590,8 @@
         </p:nvSpPr>
         <p:spPr>
           <a:xfrm>
-            <a:off x="3960000" y="18000"/>
-            <a:ext cx="1602000" cy="237600"/>
+            <a:off x="3960000" y="122400"/>
+            <a:ext cx="1602000" cy="140400"/>
           </a:xfrm>
           <a:prstGeom prst="rect">
             <a:avLst/>
@@ -7599,7 +7599,7 @@
           <a:noFill/>
         </p:spPr>
         <p:txBody>
-          <a:bodyPr wrap="square" lIns="0" rIns="0" tIns="0" bIns="0" anchor="t">
+          <a:bodyPr wrap="square" lIns="0" rIns="0" tIns="0" bIns="0" anchor="b">
             <a:noAutofit/>
           </a:bodyPr>
           <a:lstStyle/>
@@ -7796,8 +7796,8 @@
         </p:nvSpPr>
         <p:spPr>
           <a:xfrm>
-            <a:off x="28800" y="2566800"/>
-            <a:ext cx="194400" cy="93600"/>
+            <a:off x="21600" y="2566800"/>
+            <a:ext cx="208800" cy="93600"/>
           </a:xfrm>
           <a:prstGeom prst="rect">
             <a:avLst/>
@@ -7830,14 +7830,14 @@
       </p:sp>
       <p:sp>
         <p:nvSpPr>
-          <p:cNvPr id="106" name="y 3"/>
+          <p:cNvPr id="106" name="y 4"/>
           <p:cNvSpPr txBox="1"/>
           <p:nvPr/>
         </p:nvSpPr>
         <p:spPr>
           <a:xfrm>
-            <a:off x="28800" y="2881800"/>
-            <a:ext cx="194400" cy="93600"/>
+            <a:off x="21600" y="2776800"/>
+            <a:ext cx="208800" cy="93600"/>
           </a:xfrm>
           <a:prstGeom prst="rect">
             <a:avLst/>
@@ -7863,21 +7863,21 @@
                 </a:solidFill>
                 <a:latin typeface="Arial"/>
               </a:rPr>
-              <a:t>3</a:t>
-            </a:r>
-          </a:p>
-        </p:txBody>
-      </p:sp>
-      <p:sp>
-        <p:nvSpPr>
-          <p:cNvPr id="107" name="y 0"/>
+              <a:t>4</a:t>
+            </a:r>
+          </a:p>
+        </p:txBody>
+      </p:sp>
+      <p:sp>
+        <p:nvSpPr>
+          <p:cNvPr id="107" name="y 2"/>
           <p:cNvSpPr txBox="1"/>
           <p:nvPr/>
         </p:nvSpPr>
         <p:spPr>
           <a:xfrm>
-            <a:off x="28800" y="3196800"/>
-            <a:ext cx="194400" cy="93600"/>
+            <a:off x="21600" y="2986800"/>
+            <a:ext cx="208800" cy="93600"/>
           </a:xfrm>
           <a:prstGeom prst="rect">
             <a:avLst/>
@@ -7903,6 +7903,46 @@
                 </a:solidFill>
                 <a:latin typeface="Arial"/>
               </a:rPr>
+              <a:t>2</a:t>
+            </a:r>
+          </a:p>
+        </p:txBody>
+      </p:sp>
+      <p:sp>
+        <p:nvSpPr>
+          <p:cNvPr id="108" name="y 0"/>
+          <p:cNvSpPr txBox="1"/>
+          <p:nvPr/>
+        </p:nvSpPr>
+        <p:spPr>
+          <a:xfrm>
+            <a:off x="21600" y="3196800"/>
+            <a:ext cx="208800" cy="93600"/>
+          </a:xfrm>
+          <a:prstGeom prst="rect">
+            <a:avLst/>
+          </a:prstGeom>
+          <a:noFill/>
+        </p:spPr>
+        <p:txBody>
+          <a:bodyPr wrap="square" lIns="0" rIns="0" tIns="0" bIns="0" anchor="ctr">
+            <a:noAutofit/>
+          </a:bodyPr>
+          <a:lstStyle/>
+          <a:p>
+            <a:pPr algn="r">
+              <a:lnSpc>
+                <a:spcPts val="708"/>
+              </a:lnSpc>
+              <a:buNone/>
+            </a:pPr>
+            <a:r>
+              <a:rPr lang="de-DE" sz="600" b="0" i="0">
+                <a:solidFill>
+                  <a:srgbClr val="1A1A1A"/>
+                </a:solidFill>
+                <a:latin typeface="Arial"/>
+              </a:rPr>
               <a:t>0</a:t>
             </a:r>
           </a:p>
@@ -7910,7 +7950,7 @@
       </p:sp>
       <p:sp>
         <p:nvSpPr>
-          <p:cNvPr id="108" name="Jahr 2008"/>
+          <p:cNvPr id="109" name="Jahr 2008"/>
           <p:cNvSpPr txBox="1"/>
           <p:nvPr/>
         </p:nvSpPr>
@@ -7950,7 +7990,7 @@
       </p:sp>
       <p:sp>
         <p:nvSpPr>
-          <p:cNvPr id="109" name="Jahr 2012"/>
+          <p:cNvPr id="110" name="Jahr 2012"/>
           <p:cNvSpPr txBox="1"/>
           <p:nvPr/>
         </p:nvSpPr>
@@ -7990,7 +8030,7 @@
       </p:sp>
       <p:sp>
         <p:nvSpPr>
-          <p:cNvPr id="110" name="Jahr 2016"/>
+          <p:cNvPr id="111" name="Jahr 2016"/>
           <p:cNvSpPr txBox="1"/>
           <p:nvPr/>
         </p:nvSpPr>
@@ -8030,7 +8070,7 @@
       </p:sp>
       <p:sp>
         <p:nvSpPr>
-          <p:cNvPr id="111" name="Jahr 2020"/>
+          <p:cNvPr id="112" name="Jahr 2020"/>
           <p:cNvSpPr txBox="1"/>
           <p:nvPr/>
         </p:nvSpPr>
@@ -8070,14 +8110,14 @@
       </p:sp>
       <p:sp>
         <p:nvSpPr>
-          <p:cNvPr id="112" name="Fächer außen Finanzrating"/>
+          <p:cNvPr id="113" name="Bandbreite außen Finanzrating"/>
           <p:cNvSpPr/>
           <p:nvPr/>
         </p:nvSpPr>
         <p:spPr>
           <a:xfrm>
-            <a:off x="432000" y="2758500"/>
-            <a:ext cx="594000" cy="425250"/>
+            <a:off x="366000" y="2704271"/>
+            <a:ext cx="660000" cy="423919"/>
           </a:xfrm>
           <a:custGeom>
             <a:avLst/>
@@ -8086,66 +8126,72 @@
             <a:cxnLst/>
             <a:rect l="l" t="t" r="r" b="b"/>
             <a:pathLst>
-              <a:path w="594000" h="425250">
+              <a:path w="660000" h="423919">
                 <a:moveTo>
-                  <a:pt x="0" y="170100"/>
+                  <a:pt x="0" y="140329"/>
                 </a:moveTo>
                 <a:lnTo>
-                  <a:pt x="66000" y="151200"/>
-                </a:lnTo>
-                <a:lnTo>
-                  <a:pt x="132000" y="132300"/>
-                </a:lnTo>
-                <a:lnTo>
-                  <a:pt x="198000" y="113400"/>
-                </a:lnTo>
-                <a:lnTo>
-                  <a:pt x="264000" y="94500"/>
-                </a:lnTo>
-                <a:lnTo>
-                  <a:pt x="330000" y="75600"/>
-                </a:lnTo>
-                <a:lnTo>
-                  <a:pt x="396000" y="56700"/>
-                </a:lnTo>
-                <a:lnTo>
-                  <a:pt x="462000" y="37800"/>
-                </a:lnTo>
-                <a:lnTo>
-                  <a:pt x="528000" y="18900"/>
-                </a:lnTo>
-                <a:lnTo>
-                  <a:pt x="594000" y="0"/>
-                </a:lnTo>
-                <a:lnTo>
-                  <a:pt x="594000" y="425250"/>
-                </a:lnTo>
-                <a:lnTo>
-                  <a:pt x="528000" y="396900"/>
-                </a:lnTo>
-                <a:lnTo>
-                  <a:pt x="462000" y="368550"/>
-                </a:lnTo>
-                <a:lnTo>
-                  <a:pt x="396000" y="340200"/>
-                </a:lnTo>
-                <a:lnTo>
-                  <a:pt x="330000" y="311850"/>
-                </a:lnTo>
-                <a:lnTo>
-                  <a:pt x="264000" y="283500"/>
-                </a:lnTo>
-                <a:lnTo>
-                  <a:pt x="198000" y="255150"/>
-                </a:lnTo>
-                <a:lnTo>
-                  <a:pt x="132000" y="226800"/>
-                </a:lnTo>
-                <a:lnTo>
-                  <a:pt x="66000" y="198450"/>
-                </a:lnTo>
-                <a:lnTo>
-                  <a:pt x="0" y="170100"/>
+                  <a:pt x="66000" y="119423"/>
+                </a:lnTo>
+                <a:lnTo>
+                  <a:pt x="132000" y="96362"/>
+                </a:lnTo>
+                <a:lnTo>
+                  <a:pt x="198000" y="74921"/>
+                </a:lnTo>
+                <a:lnTo>
+                  <a:pt x="264000" y="56436"/>
+                </a:lnTo>
+                <a:lnTo>
+                  <a:pt x="330000" y="41122"/>
+                </a:lnTo>
+                <a:lnTo>
+                  <a:pt x="396000" y="28725"/>
+                </a:lnTo>
+                <a:lnTo>
+                  <a:pt x="462000" y="18828"/>
+                </a:lnTo>
+                <a:lnTo>
+                  <a:pt x="528000" y="10996"/>
+                </a:lnTo>
+                <a:lnTo>
+                  <a:pt x="594000" y="4833"/>
+                </a:lnTo>
+                <a:lnTo>
+                  <a:pt x="660000" y="0"/>
+                </a:lnTo>
+                <a:lnTo>
+                  <a:pt x="660000" y="423919"/>
+                </a:lnTo>
+                <a:lnTo>
+                  <a:pt x="594000" y="420919"/>
+                </a:lnTo>
+                <a:lnTo>
+                  <a:pt x="528000" y="417023"/>
+                </a:lnTo>
+                <a:lnTo>
+                  <a:pt x="462000" y="411940"/>
+                </a:lnTo>
+                <a:lnTo>
+                  <a:pt x="396000" y="405253"/>
+                </a:lnTo>
+                <a:lnTo>
+                  <a:pt x="330000" y="396357"/>
+                </a:lnTo>
+                <a:lnTo>
+                  <a:pt x="264000" y="384328"/>
+                </a:lnTo>
+                <a:lnTo>
+                  <a:pt x="198000" y="367706"/>
+                </a:lnTo>
+                <a:lnTo>
+                  <a:pt x="132000" y="344067"/>
+                </a:lnTo>
+                <a:lnTo>
+                  <a:pt x="66000" y="309246"/>
+                </a:lnTo>
+                <a:lnTo>
+                  <a:pt x="0" y="255829"/>
                 </a:lnTo>
                 <a:close/>
               </a:path>
@@ -8168,14 +8214,14 @@
       </p:sp>
       <p:sp>
         <p:nvSpPr>
-          <p:cNvPr id="113" name="Fächer innen Finanzrating"/>
+          <p:cNvPr id="114" name="Bandbreite innen Finanzrating"/>
           <p:cNvSpPr/>
           <p:nvPr/>
         </p:nvSpPr>
         <p:spPr>
           <a:xfrm>
-            <a:off x="432000" y="2843550"/>
-            <a:ext cx="594000" cy="255150"/>
+            <a:off x="366000" y="2855100"/>
+            <a:ext cx="660000" cy="174986"/>
           </a:xfrm>
           <a:custGeom>
             <a:avLst/>
@@ -8184,66 +8230,72 @@
             <a:cxnLst/>
             <a:rect l="l" t="t" r="r" b="b"/>
             <a:pathLst>
-              <a:path w="594000" h="255150">
+              <a:path w="660000" h="174986">
                 <a:moveTo>
-                  <a:pt x="0" y="85050"/>
+                  <a:pt x="0" y="0"/>
                 </a:moveTo>
                 <a:lnTo>
-                  <a:pt x="66000" y="75600"/>
-                </a:lnTo>
-                <a:lnTo>
-                  <a:pt x="132000" y="66150"/>
-                </a:lnTo>
-                <a:lnTo>
-                  <a:pt x="198000" y="56700"/>
-                </a:lnTo>
-                <a:lnTo>
-                  <a:pt x="264000" y="47250"/>
-                </a:lnTo>
-                <a:lnTo>
-                  <a:pt x="330000" y="37800"/>
-                </a:lnTo>
-                <a:lnTo>
-                  <a:pt x="396000" y="28350"/>
-                </a:lnTo>
-                <a:lnTo>
-                  <a:pt x="462000" y="18900"/>
-                </a:lnTo>
-                <a:lnTo>
-                  <a:pt x="528000" y="9450"/>
-                </a:lnTo>
-                <a:lnTo>
-                  <a:pt x="594000" y="0"/>
-                </a:lnTo>
-                <a:lnTo>
-                  <a:pt x="594000" y="255150"/>
-                </a:lnTo>
-                <a:lnTo>
-                  <a:pt x="528000" y="236250"/>
-                </a:lnTo>
-                <a:lnTo>
-                  <a:pt x="462000" y="217350"/>
-                </a:lnTo>
-                <a:lnTo>
-                  <a:pt x="396000" y="198450"/>
-                </a:lnTo>
-                <a:lnTo>
-                  <a:pt x="330000" y="179550"/>
-                </a:lnTo>
-                <a:lnTo>
-                  <a:pt x="264000" y="160650"/>
-                </a:lnTo>
-                <a:lnTo>
-                  <a:pt x="198000" y="141750"/>
-                </a:lnTo>
-                <a:lnTo>
-                  <a:pt x="132000" y="122850"/>
-                </a:lnTo>
-                <a:lnTo>
-                  <a:pt x="66000" y="103950"/>
-                </a:lnTo>
-                <a:lnTo>
-                  <a:pt x="0" y="85050"/>
+                  <a:pt x="66000" y="13933"/>
+                </a:lnTo>
+                <a:lnTo>
+                  <a:pt x="132000" y="18004"/>
+                </a:lnTo>
+                <a:lnTo>
+                  <a:pt x="198000" y="17694"/>
+                </a:lnTo>
+                <a:lnTo>
+                  <a:pt x="264000" y="15666"/>
+                </a:lnTo>
+                <a:lnTo>
+                  <a:pt x="330000" y="13169"/>
+                </a:lnTo>
+                <a:lnTo>
+                  <a:pt x="396000" y="10753"/>
+                </a:lnTo>
+                <a:lnTo>
+                  <a:pt x="462000" y="8629"/>
+                </a:lnTo>
+                <a:lnTo>
+                  <a:pt x="528000" y="6852"/>
+                </a:lnTo>
+                <a:lnTo>
+                  <a:pt x="594000" y="5403"/>
+                </a:lnTo>
+                <a:lnTo>
+                  <a:pt x="660000" y="4243"/>
+                </a:lnTo>
+                <a:lnTo>
+                  <a:pt x="660000" y="174986"/>
+                </a:lnTo>
+                <a:lnTo>
+                  <a:pt x="594000" y="173943"/>
+                </a:lnTo>
+                <a:lnTo>
+                  <a:pt x="528000" y="172562"/>
+                </a:lnTo>
+                <a:lnTo>
+                  <a:pt x="462000" y="170708"/>
+                </a:lnTo>
+                <a:lnTo>
+                  <a:pt x="396000" y="168167"/>
+                </a:lnTo>
+                <a:lnTo>
+                  <a:pt x="330000" y="164594"/>
+                </a:lnTo>
+                <a:lnTo>
+                  <a:pt x="264000" y="159401"/>
+                </a:lnTo>
+                <a:lnTo>
+                  <a:pt x="198000" y="151556"/>
+                </a:lnTo>
+                <a:lnTo>
+                  <a:pt x="132000" y="139187"/>
+                </a:lnTo>
+                <a:lnTo>
+                  <a:pt x="66000" y="118836"/>
+                </a:lnTo>
+                <a:lnTo>
+                  <a:pt x="0" y="84000"/>
                 </a:lnTo>
                 <a:close/>
               </a:path>
@@ -8266,14 +8318,14 @@
       </p:sp>
       <p:sp>
         <p:nvSpPr>
-          <p:cNvPr id="114" name="Verlauf Finanzrating"/>
+          <p:cNvPr id="115" name="Verlauf Finanzrating"/>
           <p:cNvSpPr/>
           <p:nvPr/>
         </p:nvSpPr>
         <p:spPr>
           <a:xfrm>
-            <a:off x="234000" y="2853000"/>
-            <a:ext cx="792000" cy="132300"/>
+            <a:off x="234000" y="2823600"/>
+            <a:ext cx="792000" cy="157500"/>
           </a:xfrm>
           <a:custGeom>
             <a:avLst/>
@@ -8282,45 +8334,45 @@
             <a:cxnLst/>
             <a:rect l="l" t="t" r="r" b="b"/>
             <a:pathLst>
-              <a:path w="792000" h="132300">
+              <a:path w="792000" h="157500">
                 <a:moveTo>
-                  <a:pt x="0" y="0"/>
+                  <a:pt x="0" y="157500"/>
                 </a:moveTo>
                 <a:lnTo>
-                  <a:pt x="66000" y="25200"/>
-                </a:lnTo>
-                <a:lnTo>
-                  <a:pt x="132000" y="50400"/>
-                </a:lnTo>
-                <a:lnTo>
-                  <a:pt x="198000" y="75600"/>
-                </a:lnTo>
-                <a:lnTo>
-                  <a:pt x="264000" y="81900"/>
-                </a:lnTo>
-                <a:lnTo>
-                  <a:pt x="330000" y="88200"/>
-                </a:lnTo>
-                <a:lnTo>
-                  <a:pt x="396000" y="94500"/>
-                </a:lnTo>
-                <a:lnTo>
-                  <a:pt x="462000" y="100800"/>
-                </a:lnTo>
-                <a:lnTo>
-                  <a:pt x="528000" y="107100"/>
-                </a:lnTo>
-                <a:lnTo>
-                  <a:pt x="594000" y="113400"/>
-                </a:lnTo>
-                <a:lnTo>
-                  <a:pt x="660000" y="119700"/>
-                </a:lnTo>
-                <a:lnTo>
-                  <a:pt x="726000" y="126000"/>
-                </a:lnTo>
-                <a:lnTo>
-                  <a:pt x="792000" y="132300"/>
+                  <a:pt x="66000" y="0"/>
+                </a:lnTo>
+                <a:lnTo>
+                  <a:pt x="132000" y="73500"/>
+                </a:lnTo>
+                <a:lnTo>
+                  <a:pt x="198000" y="99046"/>
+                </a:lnTo>
+                <a:lnTo>
+                  <a:pt x="264000" y="112161"/>
+                </a:lnTo>
+                <a:lnTo>
+                  <a:pt x="330000" y="118895"/>
+                </a:lnTo>
+                <a:lnTo>
+                  <a:pt x="396000" y="122352"/>
+                </a:lnTo>
+                <a:lnTo>
+                  <a:pt x="462000" y="124127"/>
+                </a:lnTo>
+                <a:lnTo>
+                  <a:pt x="528000" y="125038"/>
+                </a:lnTo>
+                <a:lnTo>
+                  <a:pt x="594000" y="125506"/>
+                </a:lnTo>
+                <a:lnTo>
+                  <a:pt x="660000" y="125747"/>
+                </a:lnTo>
+                <a:lnTo>
+                  <a:pt x="726000" y="125870"/>
+                </a:lnTo>
+                <a:lnTo>
+                  <a:pt x="792000" y="125933"/>
                 </a:lnTo>
               </a:path>
             </a:pathLst>
@@ -8343,7 +8395,7 @@
       </p:sp>
       <p:sp>
         <p:nvSpPr>
-          <p:cNvPr id="115" name="Kasten Freier Cashflow nach Steuern"/>
+          <p:cNvPr id="116" name="Kasten Freier Cashflow nach Steuern"/>
           <p:cNvSpPr/>
           <p:nvPr/>
         </p:nvSpPr>
@@ -8375,7 +8427,7 @@
       </p:sp>
       <p:sp>
         <p:nvSpPr>
-          <p:cNvPr id="116" name="Freier Cashflow nach Steuern"/>
+          <p:cNvPr id="117" name="Freier Cashflow nach Steuern"/>
           <p:cNvSpPr txBox="1"/>
           <p:nvPr/>
         </p:nvSpPr>
@@ -8433,7 +8485,7 @@
       </p:sp>
       <p:sp>
         <p:nvSpPr>
-          <p:cNvPr id="117" name="Achsen Freier Cashflow nach Steuern"/>
+          <p:cNvPr id="118" name="Achsen Freier Cashflow nach Steuern"/>
           <p:cNvSpPr/>
           <p:nvPr/>
         </p:nvSpPr>
@@ -8480,14 +8532,14 @@
       </p:sp>
       <p:sp>
         <p:nvSpPr>
-          <p:cNvPr id="118" name="y +"/>
+          <p:cNvPr id="119" name="y 400"/>
           <p:cNvSpPr txBox="1"/>
           <p:nvPr/>
         </p:nvSpPr>
         <p:spPr>
           <a:xfrm>
-            <a:off x="4546800" y="2566800"/>
-            <a:ext cx="194400" cy="93600"/>
+            <a:off x="4539600" y="2566800"/>
+            <a:ext cx="208800" cy="93600"/>
           </a:xfrm>
           <a:prstGeom prst="rect">
             <a:avLst/>
@@ -8513,21 +8565,21 @@
                 </a:solidFill>
                 <a:latin typeface="Arial"/>
               </a:rPr>
-              <a:t>+</a:t>
-            </a:r>
-          </a:p>
-        </p:txBody>
-      </p:sp>
-      <p:sp>
-        <p:nvSpPr>
-          <p:cNvPr id="119" name="y 0"/>
+              <a:t>400</a:t>
+            </a:r>
+          </a:p>
+        </p:txBody>
+      </p:sp>
+      <p:sp>
+        <p:nvSpPr>
+          <p:cNvPr id="120" name="y 200"/>
           <p:cNvSpPr txBox="1"/>
           <p:nvPr/>
         </p:nvSpPr>
         <p:spPr>
           <a:xfrm>
-            <a:off x="4546800" y="2881800"/>
-            <a:ext cx="194400" cy="93600"/>
+            <a:off x="4539600" y="2724300"/>
+            <a:ext cx="208800" cy="93600"/>
           </a:xfrm>
           <a:prstGeom prst="rect">
             <a:avLst/>
@@ -8553,21 +8605,21 @@
                 </a:solidFill>
                 <a:latin typeface="Arial"/>
               </a:rPr>
-              <a:t>0</a:t>
-            </a:r>
-          </a:p>
-        </p:txBody>
-      </p:sp>
-      <p:sp>
-        <p:nvSpPr>
-          <p:cNvPr id="120" name="y –"/>
+              <a:t>200</a:t>
+            </a:r>
+          </a:p>
+        </p:txBody>
+      </p:sp>
+      <p:sp>
+        <p:nvSpPr>
+          <p:cNvPr id="121" name="y 0"/>
           <p:cNvSpPr txBox="1"/>
           <p:nvPr/>
         </p:nvSpPr>
         <p:spPr>
           <a:xfrm>
-            <a:off x="4546800" y="3196800"/>
-            <a:ext cx="194400" cy="93600"/>
+            <a:off x="4539600" y="2881800"/>
+            <a:ext cx="208800" cy="93600"/>
           </a:xfrm>
           <a:prstGeom prst="rect">
             <a:avLst/>
@@ -8593,14 +8645,94 @@
                 </a:solidFill>
                 <a:latin typeface="Arial"/>
               </a:rPr>
-              <a:t>–</a:t>
-            </a:r>
-          </a:p>
-        </p:txBody>
-      </p:sp>
-      <p:sp>
-        <p:nvSpPr>
-          <p:cNvPr id="121" name="Jahr 2008"/>
+              <a:t>0</a:t>
+            </a:r>
+          </a:p>
+        </p:txBody>
+      </p:sp>
+      <p:sp>
+        <p:nvSpPr>
+          <p:cNvPr id="122" name="y –200"/>
+          <p:cNvSpPr txBox="1"/>
+          <p:nvPr/>
+        </p:nvSpPr>
+        <p:spPr>
+          <a:xfrm>
+            <a:off x="4539600" y="3039300"/>
+            <a:ext cx="208800" cy="93600"/>
+          </a:xfrm>
+          <a:prstGeom prst="rect">
+            <a:avLst/>
+          </a:prstGeom>
+          <a:noFill/>
+        </p:spPr>
+        <p:txBody>
+          <a:bodyPr wrap="square" lIns="0" rIns="0" tIns="0" bIns="0" anchor="ctr">
+            <a:noAutofit/>
+          </a:bodyPr>
+          <a:lstStyle/>
+          <a:p>
+            <a:pPr algn="r">
+              <a:lnSpc>
+                <a:spcPts val="708"/>
+              </a:lnSpc>
+              <a:buNone/>
+            </a:pPr>
+            <a:r>
+              <a:rPr lang="de-DE" sz="600" b="0" i="0">
+                <a:solidFill>
+                  <a:srgbClr val="1A1A1A"/>
+                </a:solidFill>
+                <a:latin typeface="Arial"/>
+              </a:rPr>
+              <a:t>–200</a:t>
+            </a:r>
+          </a:p>
+        </p:txBody>
+      </p:sp>
+      <p:sp>
+        <p:nvSpPr>
+          <p:cNvPr id="123" name="y –400"/>
+          <p:cNvSpPr txBox="1"/>
+          <p:nvPr/>
+        </p:nvSpPr>
+        <p:spPr>
+          <a:xfrm>
+            <a:off x="4539600" y="3196800"/>
+            <a:ext cx="208800" cy="93600"/>
+          </a:xfrm>
+          <a:prstGeom prst="rect">
+            <a:avLst/>
+          </a:prstGeom>
+          <a:noFill/>
+        </p:spPr>
+        <p:txBody>
+          <a:bodyPr wrap="square" lIns="0" rIns="0" tIns="0" bIns="0" anchor="ctr">
+            <a:noAutofit/>
+          </a:bodyPr>
+          <a:lstStyle/>
+          <a:p>
+            <a:pPr algn="r">
+              <a:lnSpc>
+                <a:spcPts val="708"/>
+              </a:lnSpc>
+              <a:buNone/>
+            </a:pPr>
+            <a:r>
+              <a:rPr lang="de-DE" sz="600" b="0" i="0">
+                <a:solidFill>
+                  <a:srgbClr val="1A1A1A"/>
+                </a:solidFill>
+                <a:latin typeface="Arial"/>
+              </a:rPr>
+              <a:t>–400</a:t>
+            </a:r>
+          </a:p>
+        </p:txBody>
+      </p:sp>
+      <p:sp>
+        <p:nvSpPr>
+          <p:cNvPr id="124" name="Jahr 2008"/>
           <p:cNvSpPr txBox="1"/>
           <p:nvPr/>
         </p:nvSpPr>
@@ -8640,7 +8772,7 @@
       </p:sp>
       <p:sp>
         <p:nvSpPr>
-          <p:cNvPr id="122" name="Jahr 2012"/>
+          <p:cNvPr id="125" name="Jahr 2012"/>
           <p:cNvSpPr txBox="1"/>
           <p:nvPr/>
         </p:nvSpPr>
@@ -8680,7 +8812,7 @@
       </p:sp>
       <p:sp>
         <p:nvSpPr>
-          <p:cNvPr id="123" name="Jahr 2016"/>
+          <p:cNvPr id="126" name="Jahr 2016"/>
           <p:cNvSpPr txBox="1"/>
           <p:nvPr/>
         </p:nvSpPr>
@@ -8720,7 +8852,7 @@
       </p:sp>
       <p:sp>
         <p:nvSpPr>
-          <p:cNvPr id="124" name="Jahr 2020"/>
+          <p:cNvPr id="127" name="Jahr 2020"/>
           <p:cNvSpPr txBox="1"/>
           <p:nvPr/>
         </p:nvSpPr>
@@ -8760,14 +8892,14 @@
       </p:sp>
       <p:sp>
         <p:nvSpPr>
-          <p:cNvPr id="125" name="Fächer außen Freier Cashflow nach Steuern"/>
+          <p:cNvPr id="128" name="Bandbreite außen Freier Cashflow nach Steuern"/>
           <p:cNvSpPr/>
           <p:nvPr/>
         </p:nvSpPr>
         <p:spPr>
           <a:xfrm>
-            <a:off x="4909500" y="2673450"/>
-            <a:ext cx="472500" cy="453600"/>
+            <a:off x="4857000" y="2654449"/>
+            <a:ext cx="525000" cy="486776"/>
           </a:xfrm>
           <a:custGeom>
             <a:avLst/>
@@ -8776,66 +8908,72 @@
             <a:cxnLst/>
             <a:rect l="l" t="t" r="r" b="b"/>
             <a:pathLst>
-              <a:path w="472500" h="453600">
+              <a:path w="525000" h="486776">
                 <a:moveTo>
-                  <a:pt x="0" y="255150"/>
+                  <a:pt x="0" y="486776"/>
                 </a:moveTo>
                 <a:lnTo>
-                  <a:pt x="52500" y="226800"/>
-                </a:lnTo>
-                <a:lnTo>
-                  <a:pt x="105000" y="198450"/>
-                </a:lnTo>
-                <a:lnTo>
-                  <a:pt x="157500" y="170100"/>
-                </a:lnTo>
-                <a:lnTo>
-                  <a:pt x="210000" y="141750"/>
-                </a:lnTo>
-                <a:lnTo>
-                  <a:pt x="262500" y="113400"/>
-                </a:lnTo>
-                <a:lnTo>
-                  <a:pt x="315000" y="85050"/>
-                </a:lnTo>
-                <a:lnTo>
-                  <a:pt x="367500" y="56700"/>
-                </a:lnTo>
-                <a:lnTo>
-                  <a:pt x="420000" y="28350"/>
-                </a:lnTo>
-                <a:lnTo>
-                  <a:pt x="472500" y="0"/>
-                </a:lnTo>
-                <a:lnTo>
-                  <a:pt x="472500" y="453600"/>
-                </a:lnTo>
-                <a:lnTo>
-                  <a:pt x="420000" y="431550"/>
-                </a:lnTo>
-                <a:lnTo>
-                  <a:pt x="367500" y="409500"/>
-                </a:lnTo>
-                <a:lnTo>
-                  <a:pt x="315000" y="387450"/>
-                </a:lnTo>
-                <a:lnTo>
-                  <a:pt x="262500" y="365400"/>
-                </a:lnTo>
-                <a:lnTo>
-                  <a:pt x="210000" y="343350"/>
-                </a:lnTo>
-                <a:lnTo>
-                  <a:pt x="157500" y="321300"/>
-                </a:lnTo>
-                <a:lnTo>
-                  <a:pt x="105000" y="299250"/>
-                </a:lnTo>
-                <a:lnTo>
-                  <a:pt x="52500" y="277200"/>
-                </a:lnTo>
-                <a:lnTo>
-                  <a:pt x="0" y="255150"/>
+                  <a:pt x="52500" y="413609"/>
+                </a:lnTo>
+                <a:lnTo>
+                  <a:pt x="105000" y="386072"/>
+                </a:lnTo>
+                <a:lnTo>
+                  <a:pt x="157500" y="376690"/>
+                </a:lnTo>
+                <a:lnTo>
+                  <a:pt x="210000" y="374180"/>
+                </a:lnTo>
+                <a:lnTo>
+                  <a:pt x="262500" y="374041"/>
+                </a:lnTo>
+                <a:lnTo>
+                  <a:pt x="315000" y="374557"/>
+                </a:lnTo>
+                <a:lnTo>
+                  <a:pt x="367500" y="375131"/>
+                </a:lnTo>
+                <a:lnTo>
+                  <a:pt x="420000" y="375593"/>
+                </a:lnTo>
+                <a:lnTo>
+                  <a:pt x="472500" y="375922"/>
+                </a:lnTo>
+                <a:lnTo>
+                  <a:pt x="525000" y="376143"/>
+                </a:lnTo>
+                <a:lnTo>
+                  <a:pt x="525000" y="0"/>
+                </a:lnTo>
+                <a:lnTo>
+                  <a:pt x="472500" y="984"/>
+                </a:lnTo>
+                <a:lnTo>
+                  <a:pt x="420000" y="2641"/>
+                </a:lnTo>
+                <a:lnTo>
+                  <a:pt x="367500" y="5454"/>
+                </a:lnTo>
+                <a:lnTo>
+                  <a:pt x="315000" y="10279"/>
+                </a:lnTo>
+                <a:lnTo>
+                  <a:pt x="262500" y="18665"/>
+                </a:lnTo>
+                <a:lnTo>
+                  <a:pt x="210000" y="33482"/>
+                </a:lnTo>
+                <a:lnTo>
+                  <a:pt x="157500" y="60190"/>
+                </a:lnTo>
+                <a:lnTo>
+                  <a:pt x="105000" y="109469"/>
+                </a:lnTo>
+                <a:lnTo>
+                  <a:pt x="52500" y="202784"/>
+                </a:lnTo>
+                <a:lnTo>
+                  <a:pt x="0" y="384401"/>
                 </a:lnTo>
                 <a:close/>
               </a:path>
@@ -8858,14 +8996,14 @@
       </p:sp>
       <p:sp>
         <p:nvSpPr>
-          <p:cNvPr id="126" name="Fächer innen Freier Cashflow nach Steuern"/>
+          <p:cNvPr id="129" name="Bandbreite innen Freier Cashflow nach Steuern"/>
           <p:cNvSpPr/>
           <p:nvPr/>
         </p:nvSpPr>
         <p:spPr>
           <a:xfrm>
-            <a:off x="4909500" y="2758500"/>
-            <a:ext cx="472500" cy="283500"/>
+            <a:off x="4857000" y="2818869"/>
+            <a:ext cx="525000" cy="290856"/>
           </a:xfrm>
           <a:custGeom>
             <a:avLst/>
@@ -8874,66 +9012,72 @@
             <a:cxnLst/>
             <a:rect l="l" t="t" r="r" b="b"/>
             <a:pathLst>
-              <a:path w="472500" h="283500">
+              <a:path w="525000" h="290856">
                 <a:moveTo>
-                  <a:pt x="0" y="170100"/>
+                  <a:pt x="0" y="290856"/>
                 </a:moveTo>
                 <a:lnTo>
-                  <a:pt x="52500" y="151200"/>
-                </a:lnTo>
-                <a:lnTo>
-                  <a:pt x="105000" y="132300"/>
-                </a:lnTo>
-                <a:lnTo>
-                  <a:pt x="157500" y="113400"/>
-                </a:lnTo>
-                <a:lnTo>
-                  <a:pt x="210000" y="94500"/>
-                </a:lnTo>
-                <a:lnTo>
-                  <a:pt x="262500" y="75600"/>
-                </a:lnTo>
-                <a:lnTo>
-                  <a:pt x="315000" y="56700"/>
-                </a:lnTo>
-                <a:lnTo>
-                  <a:pt x="367500" y="37800"/>
-                </a:lnTo>
-                <a:lnTo>
-                  <a:pt x="420000" y="18900"/>
-                </a:lnTo>
-                <a:lnTo>
-                  <a:pt x="472500" y="0"/>
-                </a:lnTo>
-                <a:lnTo>
-                  <a:pt x="472500" y="283500"/>
-                </a:lnTo>
-                <a:lnTo>
-                  <a:pt x="420000" y="270900"/>
-                </a:lnTo>
-                <a:lnTo>
-                  <a:pt x="367500" y="258300"/>
-                </a:lnTo>
-                <a:lnTo>
-                  <a:pt x="315000" y="245700"/>
-                </a:lnTo>
-                <a:lnTo>
-                  <a:pt x="262500" y="233100"/>
-                </a:lnTo>
-                <a:lnTo>
-                  <a:pt x="210000" y="220500"/>
-                </a:lnTo>
-                <a:lnTo>
-                  <a:pt x="157500" y="207900"/>
-                </a:lnTo>
-                <a:lnTo>
-                  <a:pt x="105000" y="195300"/>
-                </a:lnTo>
-                <a:lnTo>
-                  <a:pt x="52500" y="182700"/>
-                </a:lnTo>
-                <a:lnTo>
-                  <a:pt x="0" y="170100"/>
+                  <a:pt x="52500" y="214590"/>
+                </a:lnTo>
+                <a:lnTo>
+                  <a:pt x="105000" y="185174"/>
+                </a:lnTo>
+                <a:lnTo>
+                  <a:pt x="157500" y="174652"/>
+                </a:lnTo>
+                <a:lnTo>
+                  <a:pt x="210000" y="171451"/>
+                </a:lnTo>
+                <a:lnTo>
+                  <a:pt x="262500" y="170892"/>
+                </a:lnTo>
+                <a:lnTo>
+                  <a:pt x="315000" y="171154"/>
+                </a:lnTo>
+                <a:lnTo>
+                  <a:pt x="367500" y="171574"/>
+                </a:lnTo>
+                <a:lnTo>
+                  <a:pt x="420000" y="171942"/>
+                </a:lnTo>
+                <a:lnTo>
+                  <a:pt x="472500" y="172214"/>
+                </a:lnTo>
+                <a:lnTo>
+                  <a:pt x="525000" y="172401"/>
+                </a:lnTo>
+                <a:lnTo>
+                  <a:pt x="525000" y="0"/>
+                </a:lnTo>
+                <a:lnTo>
+                  <a:pt x="472500" y="364"/>
+                </a:lnTo>
+                <a:lnTo>
+                  <a:pt x="420000" y="1000"/>
+                </a:lnTo>
+                <a:lnTo>
+                  <a:pt x="367500" y="2129"/>
+                </a:lnTo>
+                <a:lnTo>
+                  <a:pt x="315000" y="4177"/>
+                </a:lnTo>
+                <a:lnTo>
+                  <a:pt x="262500" y="7985"/>
+                </a:lnTo>
+                <a:lnTo>
+                  <a:pt x="210000" y="15253"/>
+                </a:lnTo>
+                <a:lnTo>
+                  <a:pt x="157500" y="29517"/>
+                </a:lnTo>
+                <a:lnTo>
+                  <a:pt x="105000" y="58277"/>
+                </a:lnTo>
+                <a:lnTo>
+                  <a:pt x="52500" y="117763"/>
+                </a:lnTo>
+                <a:lnTo>
+                  <a:pt x="0" y="243606"/>
                 </a:lnTo>
                 <a:close/>
               </a:path>
@@ -8956,14 +9100,14 @@
       </p:sp>
       <p:sp>
         <p:nvSpPr>
-          <p:cNvPr id="127" name="Verlauf Freier Cashflow nach Steuern"/>
+          <p:cNvPr id="130" name="Verlauf Freier Cashflow nach Steuern"/>
           <p:cNvSpPr/>
           <p:nvPr/>
         </p:nvSpPr>
         <p:spPr>
           <a:xfrm>
-            <a:off x="4752000" y="2815434"/>
-            <a:ext cx="630000" cy="207666"/>
+            <a:off x="4752000" y="2849850"/>
+            <a:ext cx="630000" cy="236250"/>
           </a:xfrm>
           <a:custGeom>
             <a:avLst/>
@@ -8972,45 +9116,45 @@
             <a:cxnLst/>
             <a:rect l="l" t="t" r="r" b="b"/>
             <a:pathLst>
-              <a:path w="630000" h="207666">
+              <a:path w="630000" h="236250">
                 <a:moveTo>
-                  <a:pt x="0" y="207666"/>
+                  <a:pt x="0" y="0"/>
                 </a:moveTo>
                 <a:lnTo>
-                  <a:pt x="52500" y="207666"/>
-                </a:lnTo>
-                <a:lnTo>
-                  <a:pt x="105000" y="207666"/>
-                </a:lnTo>
-                <a:lnTo>
-                  <a:pt x="157500" y="207666"/>
-                </a:lnTo>
-                <a:lnTo>
-                  <a:pt x="210000" y="149084"/>
-                </a:lnTo>
-                <a:lnTo>
-                  <a:pt x="262500" y="112876"/>
-                </a:lnTo>
-                <a:lnTo>
-                  <a:pt x="315000" y="88155"/>
-                </a:lnTo>
-                <a:lnTo>
-                  <a:pt x="367500" y="69332"/>
-                </a:lnTo>
-                <a:lnTo>
-                  <a:pt x="420000" y="53537"/>
-                </a:lnTo>
-                <a:lnTo>
-                  <a:pt x="472500" y="39297"/>
-                </a:lnTo>
-                <a:lnTo>
-                  <a:pt x="525000" y="25855"/>
-                </a:lnTo>
-                <a:lnTo>
-                  <a:pt x="577500" y="12822"/>
-                </a:lnTo>
-                <a:lnTo>
-                  <a:pt x="630000" y="0"/>
+                  <a:pt x="52500" y="47250"/>
+                </a:lnTo>
+                <a:lnTo>
+                  <a:pt x="105000" y="236250"/>
+                </a:lnTo>
+                <a:lnTo>
+                  <a:pt x="157500" y="138294"/>
+                </a:lnTo>
+                <a:lnTo>
+                  <a:pt x="210000" y="95723"/>
+                </a:lnTo>
+                <a:lnTo>
+                  <a:pt x="262500" y="77221"/>
+                </a:lnTo>
+                <a:lnTo>
+                  <a:pt x="315000" y="69181"/>
+                </a:lnTo>
+                <a:lnTo>
+                  <a:pt x="367500" y="65686"/>
+                </a:lnTo>
+                <a:lnTo>
+                  <a:pt x="420000" y="64167"/>
+                </a:lnTo>
+                <a:lnTo>
+                  <a:pt x="472500" y="63507"/>
+                </a:lnTo>
+                <a:lnTo>
+                  <a:pt x="525000" y="63220"/>
+                </a:lnTo>
+                <a:lnTo>
+                  <a:pt x="577500" y="63096"/>
+                </a:lnTo>
+                <a:lnTo>
+                  <a:pt x="630000" y="63042"/>
                 </a:lnTo>
               </a:path>
             </a:pathLst>
@@ -9033,7 +9177,7 @@
       </p:sp>
       <p:sp>
         <p:nvSpPr>
-          <p:cNvPr id="128" name="Ratingtabelle"/>
+          <p:cNvPr id="131" name="Ratingtabelle"/>
           <p:cNvSpPr/>
           <p:nvPr/>
         </p:nvSpPr>
@@ -9065,7 +9209,7 @@
       </p:sp>
       <p:sp>
         <p:nvSpPr>
-          <p:cNvPr id="129" name="Titel Ratingtabelle"/>
+          <p:cNvPr id="132" name="Titel Ratingtabelle"/>
           <p:cNvSpPr txBox="1"/>
           <p:nvPr/>
         </p:nvSpPr>
@@ -9123,7 +9267,7 @@
       </p:sp>
       <p:sp>
         <p:nvSpPr>
-          <p:cNvPr id="130" name="Tabellenkopf"/>
+          <p:cNvPr id="133" name="Tabellenkopf"/>
           <p:cNvSpPr/>
           <p:nvPr/>
         </p:nvSpPr>
@@ -9150,7 +9294,7 @@
       </p:sp>
       <p:sp>
         <p:nvSpPr>
-          <p:cNvPr id="131" name="Kopf Note"/>
+          <p:cNvPr id="134" name="Kopf Note"/>
           <p:cNvSpPr txBox="1"/>
           <p:nvPr/>
         </p:nvSpPr>
@@ -9190,7 +9334,7 @@
       </p:sp>
       <p:sp>
         <p:nvSpPr>
-          <p:cNvPr id="132" name="Kopf PD"/>
+          <p:cNvPr id="135" name="Kopf PD"/>
           <p:cNvSpPr txBox="1"/>
           <p:nvPr/>
         </p:nvSpPr>
@@ -9230,7 +9374,7 @@
       </p:sp>
       <p:sp>
         <p:nvSpPr>
-          <p:cNvPr id="133" name="Klasse AAA"/>
+          <p:cNvPr id="136" name="Klasse AAA"/>
           <p:cNvSpPr txBox="1"/>
           <p:nvPr/>
         </p:nvSpPr>
@@ -9270,7 +9414,7 @@
       </p:sp>
       <p:sp>
         <p:nvSpPr>
-          <p:cNvPr id="134" name="PD AAA"/>
+          <p:cNvPr id="137" name="PD AAA"/>
           <p:cNvSpPr txBox="1"/>
           <p:nvPr/>
         </p:nvSpPr>
@@ -9310,7 +9454,7 @@
       </p:sp>
       <p:sp>
         <p:nvSpPr>
-          <p:cNvPr id="135" name="Linie AAA"/>
+          <p:cNvPr id="138" name="Linie AAA"/>
           <p:cNvSpPr/>
           <p:nvPr/>
         </p:nvSpPr>
@@ -9354,7 +9498,7 @@
       </p:sp>
       <p:sp>
         <p:nvSpPr>
-          <p:cNvPr id="136" name="Klasse AA"/>
+          <p:cNvPr id="139" name="Klasse AA"/>
           <p:cNvSpPr txBox="1"/>
           <p:nvPr/>
         </p:nvSpPr>
@@ -9394,7 +9538,7 @@
       </p:sp>
       <p:sp>
         <p:nvSpPr>
-          <p:cNvPr id="137" name="PD AA"/>
+          <p:cNvPr id="140" name="PD AA"/>
           <p:cNvSpPr txBox="1"/>
           <p:nvPr/>
         </p:nvSpPr>
@@ -9434,7 +9578,7 @@
       </p:sp>
       <p:sp>
         <p:nvSpPr>
-          <p:cNvPr id="138" name="Linie AA"/>
+          <p:cNvPr id="141" name="Linie AA"/>
           <p:cNvSpPr/>
           <p:nvPr/>
         </p:nvSpPr>
@@ -9478,7 +9622,7 @@
       </p:sp>
       <p:sp>
         <p:nvSpPr>
-          <p:cNvPr id="139" name="Klasse A"/>
+          <p:cNvPr id="142" name="Klasse A"/>
           <p:cNvSpPr txBox="1"/>
           <p:nvPr/>
         </p:nvSpPr>
@@ -9518,7 +9662,7 @@
       </p:sp>
       <p:sp>
         <p:nvSpPr>
-          <p:cNvPr id="140" name="PD A"/>
+          <p:cNvPr id="143" name="PD A"/>
           <p:cNvSpPr txBox="1"/>
           <p:nvPr/>
         </p:nvSpPr>
@@ -9558,7 +9702,7 @@
       </p:sp>
       <p:sp>
         <p:nvSpPr>
-          <p:cNvPr id="141" name="Linie A"/>
+          <p:cNvPr id="144" name="Linie A"/>
           <p:cNvSpPr/>
           <p:nvPr/>
         </p:nvSpPr>
@@ -9602,7 +9746,7 @@
       </p:sp>
       <p:sp>
         <p:nvSpPr>
-          <p:cNvPr id="142" name="Klasse BBB"/>
+          <p:cNvPr id="145" name="Klasse BBB"/>
           <p:cNvSpPr txBox="1"/>
           <p:nvPr/>
         </p:nvSpPr>
@@ -9642,7 +9786,7 @@
       </p:sp>
       <p:sp>
         <p:nvSpPr>
-          <p:cNvPr id="143" name="PD BBB"/>
+          <p:cNvPr id="146" name="PD BBB"/>
           <p:cNvSpPr txBox="1"/>
           <p:nvPr/>
         </p:nvSpPr>
@@ -9682,7 +9826,7 @@
       </p:sp>
       <p:sp>
         <p:nvSpPr>
-          <p:cNvPr id="144" name="Linie BBB"/>
+          <p:cNvPr id="147" name="Linie BBB"/>
           <p:cNvSpPr/>
           <p:nvPr/>
         </p:nvSpPr>
@@ -9726,7 +9870,7 @@
       </p:sp>
       <p:sp>
         <p:nvSpPr>
-          <p:cNvPr id="145" name="Klasse BB"/>
+          <p:cNvPr id="148" name="Klasse BB"/>
           <p:cNvSpPr txBox="1"/>
           <p:nvPr/>
         </p:nvSpPr>
@@ -9766,7 +9910,7 @@
       </p:sp>
       <p:sp>
         <p:nvSpPr>
-          <p:cNvPr id="146" name="PD BB"/>
+          <p:cNvPr id="149" name="PD BB"/>
           <p:cNvSpPr txBox="1"/>
           <p:nvPr/>
         </p:nvSpPr>
@@ -9806,7 +9950,7 @@
       </p:sp>
       <p:sp>
         <p:nvSpPr>
-          <p:cNvPr id="147" name="Linie BB"/>
+          <p:cNvPr id="150" name="Linie BB"/>
           <p:cNvSpPr/>
           <p:nvPr/>
         </p:nvSpPr>
@@ -9850,7 +9994,7 @@
       </p:sp>
       <p:sp>
         <p:nvSpPr>
-          <p:cNvPr id="148" name="Klasse B+"/>
+          <p:cNvPr id="151" name="Klasse B+"/>
           <p:cNvSpPr txBox="1"/>
           <p:nvPr/>
         </p:nvSpPr>
@@ -9890,7 +10034,7 @@
       </p:sp>
       <p:sp>
         <p:nvSpPr>
-          <p:cNvPr id="149" name="PD B+"/>
+          <p:cNvPr id="152" name="PD B+"/>
           <p:cNvSpPr txBox="1"/>
           <p:nvPr/>
         </p:nvSpPr>
@@ -9930,7 +10074,7 @@
       </p:sp>
       <p:sp>
         <p:nvSpPr>
-          <p:cNvPr id="150" name="Linie B+"/>
+          <p:cNvPr id="153" name="Linie B+"/>
           <p:cNvSpPr/>
           <p:nvPr/>
         </p:nvSpPr>
@@ -9974,7 +10118,7 @@
       </p:sp>
       <p:sp>
         <p:nvSpPr>
-          <p:cNvPr id="151" name="Schätzung PD"/>
+          <p:cNvPr id="154" name="Schätzung PD"/>
           <p:cNvSpPr/>
           <p:nvPr/>
         </p:nvSpPr>
@@ -10118,7 +10262,7 @@
       </p:sp>
       <p:sp>
         <p:nvSpPr>
-          <p:cNvPr id="152" name="Gewinn → Simulation"/>
+          <p:cNvPr id="155" name="Gewinn → Simulation"/>
           <p:cNvSpPr/>
           <p:nvPr/>
         </p:nvSpPr>
@@ -10163,7 +10307,7 @@
       </p:sp>
       <p:sp>
         <p:nvSpPr>
-          <p:cNvPr id="153" name="Simulation → Schätzung"/>
+          <p:cNvPr id="156" name="Simulation → Schätzung"/>
           <p:cNvSpPr/>
           <p:nvPr/>
         </p:nvSpPr>
@@ -10214,7 +10358,7 @@
       </p:sp>
       <p:sp>
         <p:nvSpPr>
-          <p:cNvPr id="154" name="Simulation → Cashflow"/>
+          <p:cNvPr id="157" name="Simulation → Cashflow"/>
           <p:cNvSpPr/>
           <p:nvPr/>
         </p:nvSpPr>
@@ -10259,7 +10403,7 @@
       </p:sp>
       <p:sp>
         <p:nvSpPr>
-          <p:cNvPr id="155" name="Schätzung → Ratingtabelle"/>
+          <p:cNvPr id="158" name="Schätzung → Ratingtabelle"/>
           <p:cNvSpPr/>
           <p:nvPr/>
         </p:nvSpPr>
@@ -10304,7 +10448,7 @@
       </p:sp>
       <p:sp>
         <p:nvSpPr>
-          <p:cNvPr id="156" name="Ratingtabelle → Finanzrating"/>
+          <p:cNvPr id="159" name="Ratingtabelle → Finanzrating"/>
           <p:cNvSpPr/>
           <p:nvPr/>
         </p:nvSpPr>

</xml_diff>